<commit_message>
Slight updates to the HTN exercise.
</commit_message>
<xml_diff>
--- a/exercises/cisc-813/htn/slides.pptx
+++ b/exercises/cisc-813/htn/slides.pptx
@@ -693,7 +693,7 @@
           <a:p>
             <a:fld id="{D6D0F569-AC90-44EB-9EF4-4E5C2F5D823C}" type="datetime1">
               <a:rPr lang="en-US" smtClean="0"/>
-              <a:t>11/5/2024</a:t>
+              <a:t>11/5/2025</a:t>
             </a:fld>
             <a:endParaRPr lang="en-US" dirty="0"/>
           </a:p>
@@ -1372,7 +1372,7 @@
           <a:p>
             <a:fld id="{46BA7D41-E8B7-4A0B-B861-3EC4AE88917D}" type="datetime1">
               <a:rPr lang="en-US" smtClean="0"/>
-              <a:t>11/5/2024</a:t>
+              <a:t>11/5/2025</a:t>
             </a:fld>
             <a:endParaRPr lang="en-US" dirty="0"/>
           </a:p>
@@ -2061,7 +2061,7 @@
           <a:p>
             <a:fld id="{A7C34823-0B19-4B4E-A643-7A3B0A3D24D6}" type="datetime1">
               <a:rPr lang="en-US" smtClean="0"/>
-              <a:t>11/5/2024</a:t>
+              <a:t>11/5/2025</a:t>
             </a:fld>
             <a:endParaRPr lang="en-US" dirty="0"/>
           </a:p>
@@ -3184,7 +3184,7 @@
           <a:p>
             <a:fld id="{8C2D79EF-17C8-45D8-9866-DAF5723FC604}" type="datetime1">
               <a:rPr lang="en-US" smtClean="0"/>
-              <a:t>11/5/2024</a:t>
+              <a:t>11/5/2025</a:t>
             </a:fld>
             <a:endParaRPr lang="en-US" dirty="0"/>
           </a:p>
@@ -3939,7 +3939,7 @@
           <a:p>
             <a:fld id="{DFFC2ADC-3680-4013-A757-E4663495DB98}" type="datetime1">
               <a:rPr lang="en-US" smtClean="0"/>
-              <a:t>11/5/2024</a:t>
+              <a:t>11/5/2025</a:t>
             </a:fld>
             <a:endParaRPr lang="en-US" dirty="0"/>
           </a:p>
@@ -4686,7 +4686,7 @@
           <a:p>
             <a:fld id="{4751BA94-5DCA-4F19-960F-0FB2BD5EE85A}" type="datetime1">
               <a:rPr lang="en-US" smtClean="0"/>
-              <a:t>11/5/2024</a:t>
+              <a:t>11/5/2025</a:t>
             </a:fld>
             <a:endParaRPr lang="en-US" dirty="0"/>
           </a:p>
@@ -5580,7 +5580,7 @@
           <a:p>
             <a:fld id="{01BED947-38D9-44AC-8B89-E79758333B77}" type="datetime1">
               <a:rPr lang="en-US" smtClean="0"/>
-              <a:t>11/5/2024</a:t>
+              <a:t>11/5/2025</a:t>
             </a:fld>
             <a:endParaRPr lang="en-US" dirty="0"/>
           </a:p>
@@ -6201,7 +6201,7 @@
           <a:p>
             <a:fld id="{3781E23F-BD3C-4F23-B116-2B758120C8AC}" type="datetime1">
               <a:rPr lang="en-US" smtClean="0"/>
-              <a:t>11/5/2024</a:t>
+              <a:t>11/5/2025</a:t>
             </a:fld>
             <a:endParaRPr lang="en-US" dirty="0"/>
           </a:p>
@@ -6793,7 +6793,7 @@
           <a:p>
             <a:fld id="{473CFAA9-6D59-4D98-869E-ACBDB83B2CA4}" type="datetime1">
               <a:rPr lang="en-US" smtClean="0"/>
-              <a:t>11/5/2024</a:t>
+              <a:t>11/5/2025</a:t>
             </a:fld>
             <a:endParaRPr lang="en-US"/>
           </a:p>
@@ -7585,7 +7585,7 @@
           <a:p>
             <a:fld id="{DC410804-27E3-430A-BB42-B831260DE39A}" type="datetime1">
               <a:rPr lang="en-US" smtClean="0"/>
-              <a:t>11/5/2024</a:t>
+              <a:t>11/5/2025</a:t>
             </a:fld>
             <a:endParaRPr lang="en-US" dirty="0"/>
           </a:p>
@@ -8356,7 +8356,7 @@
           <a:p>
             <a:fld id="{60E22DE3-3D1A-4D53-B9A6-6C7463B8C992}" type="datetime1">
               <a:rPr lang="en-US" smtClean="0"/>
-              <a:t>11/5/2024</a:t>
+              <a:t>11/5/2025</a:t>
             </a:fld>
             <a:endParaRPr lang="en-US" dirty="0"/>
           </a:p>
@@ -8667,7 +8667,7 @@
             <a:fld id="{5ECD8B30-1B71-45A1-8314-D59C86F581E1}" type="datetime1">
               <a:rPr lang="en-US" smtClean="0"/>
               <a:pPr/>
-              <a:t>11/5/2024</a:t>
+              <a:t>11/5/2025</a:t>
             </a:fld>
             <a:endParaRPr lang="en-US" b="1" dirty="0"/>
           </a:p>
@@ -10377,13 +10377,13 @@
   <p:clrMapOvr>
     <a:masterClrMapping/>
   </p:clrMapOvr>
-  <mc:AlternateContent xmlns:mc="http://schemas.openxmlformats.org/markup-compatibility/2006">
-    <mc:Choice xmlns:p14="http://schemas.microsoft.com/office/powerpoint/2010/main" Requires="p14">
+  <mc:AlternateContent xmlns:mc="http://schemas.openxmlformats.org/markup-compatibility/2006" xmlns:p14="http://schemas.microsoft.com/office/powerpoint/2010/main">
+    <mc:Choice Requires="p14">
       <p:transition spd="med" p14:dur="700">
         <p:fade/>
       </p:transition>
     </mc:Choice>
-    <mc:Fallback>
+    <mc:Fallback xmlns="">
       <p:transition spd="med">
         <p:fade/>
       </p:transition>
@@ -10478,7 +10478,19 @@
             </a:r>
             <a:r>
               <a:rPr lang="en-US" i="1" dirty="0"/>
-              <a:t> + PDDL Plugin</a:t>
+              <a:t> + </a:t>
+            </a:r>
+            <a:r>
+              <a:rPr lang="en-US" b="1" i="1" dirty="0">
+                <a:solidFill>
+                  <a:schemeClr val="accent1"/>
+                </a:solidFill>
+              </a:rPr>
+              <a:t>H</a:t>
+            </a:r>
+            <a:r>
+              <a:rPr lang="en-US" i="1" dirty="0"/>
+              <a:t>DDL Plugin</a:t>
             </a:r>
           </a:p>
           <a:p>
@@ -11429,7 +11441,7 @@
         </p:spPr>
         <p:txBody>
           <a:bodyPr>
-            <a:normAutofit fontScale="92500"/>
+            <a:normAutofit lnSpcReduction="10000"/>
           </a:bodyPr>
           <a:lstStyle/>
           <a:p>
@@ -11560,7 +11572,7 @@
             </a:r>
             <a:r>
               <a:rPr lang="en-CA" dirty="0"/>
-              <a:t>: Recursive definition to prepare an ingredient</a:t>
+              <a:t>: Recursive definition to prepare ingredients</a:t>
             </a:r>
           </a:p>
           <a:p>

</xml_diff>